<commit_message>
chore(eval): commit the extraction evaluation report
Seven of seven sample documents scored, none failed: 94.5% field accuracy and
100% line item accuracy against the hand-written answer key.

Twelve of the thirteen scored fields are at 100%. subtotal sits at 28.6%
because the run predates the prompt fix for net-total label synonyms, which is
exactly the systematic weakness a per-field breakdown exists to surface.

The deck reads these numbers at build time. Match rate, exception detection and
straight-through render as "--" rather than 0% because extraction mode measures
none of them; an unmeasured metric shown as zero reads as a failure.
</commit_message>
<xml_diff>
--- a/docs/Invoice-to-Payment-Agent-Solution-Deck.pptx
+++ b/docs/Invoice-to-Payment-Agent-Solution-Deck.pptx
@@ -5852,7 +5852,7 @@
                 </a:solidFill>
                 <a:latin typeface="Calibri"/>
               </a:rPr>
-              <a:t>0%</a:t>
+              <a:t>95%</a:t>
             </a:r>
           </a:p>
         </p:txBody>
@@ -5978,7 +5978,7 @@
                 </a:solidFill>
                 <a:latin typeface="Calibri"/>
               </a:rPr>
-              <a:t>0%</a:t>
+              <a:t>100%</a:t>
             </a:r>
           </a:p>
         </p:txBody>
@@ -6104,7 +6104,7 @@
                 </a:solidFill>
                 <a:latin typeface="Calibri"/>
               </a:rPr>
-              <a:t>0%</a:t>
+              <a:t>--</a:t>
             </a:r>
           </a:p>
         </p:txBody>
@@ -6230,7 +6230,7 @@
                 </a:solidFill>
                 <a:latin typeface="Calibri"/>
               </a:rPr>
-              <a:t>0%</a:t>
+              <a:t>--</a:t>
             </a:r>
           </a:p>
         </p:txBody>
@@ -6356,7 +6356,7 @@
                 </a:solidFill>
                 <a:latin typeface="Calibri"/>
               </a:rPr>
-              <a:t>n/a</a:t>
+              <a:t>--</a:t>
             </a:r>
           </a:p>
         </p:txBody>
@@ -6438,7 +6438,7 @@
                 </a:solidFill>
                 <a:latin typeface="Calibri"/>
               </a:rPr>
-              <a:t>0 of 7 sample documents scored  |  mode: extraction  |  model: llama3.1:8b via Ollama</a:t>
+              <a:t>7 of 7 sample documents scored, 0 failed  |  mode: extraction  |  model: llama3.1:8b via Ollama    (--  measured only in e2e mode, against the running stack)</a:t>
             </a:r>
           </a:p>
         </p:txBody>
@@ -9867,7 +9867,7 @@
                 </a:solidFill>
                 <a:latin typeface="Calibri"/>
               </a:rPr>
-              <a:t>Invoices arrive as email attachments: native PDFs, scans, and HTML, in no fixed layout.</a:t>
+              <a:t>Invoices arrive as email attachments: native PDFs, scans and HTML, in no fixed layout.</a:t>
             </a:r>
           </a:p>
         </p:txBody>

</xml_diff>